<commit_message>
add: modify NTT part
</commit_message>
<xml_diff>
--- a/presentation/0903_14_Introduction-to-Hash-Based-Signatures.pptx
+++ b/presentation/0903_14_Introduction-to-Hash-Based-Signatures.pptx
@@ -228,7 +228,7 @@
           <a:p>
             <a:fld id="{B52B40C2-3351-40A2-B46D-4B4F877A79B2}" type="datetimeFigureOut">
               <a:rPr lang="ko-KR" altLang="en-US" smtClean="0"/>
-              <a:t>2026-08-31</a:t>
+              <a:t>2026-09-02</a:t>
             </a:fld>
             <a:endParaRPr lang="ko-KR" altLang="en-US" dirty="0"/>
           </a:p>
@@ -495,6 +495,102 @@
 </p:notesMaster>
 </file>
 
+<file path=ppt/notesSlides/notesSlide1.xml><?xml version="1.0" encoding="utf-8"?>
+<p:notes xmlns:a="http://schemas.openxmlformats.org/drawingml/2006/main" xmlns:r="http://schemas.openxmlformats.org/officeDocument/2006/relationships" xmlns:p="http://schemas.openxmlformats.org/presentationml/2006/main">
+  <p:cSld>
+    <p:spTree>
+      <p:nvGrpSpPr>
+        <p:cNvPr id="1" name=""/>
+        <p:cNvGrpSpPr/>
+        <p:nvPr/>
+      </p:nvGrpSpPr>
+      <p:grpSpPr>
+        <a:xfrm>
+          <a:off x="0" y="0"/>
+          <a:ext cx="0" cy="0"/>
+          <a:chOff x="0" y="0"/>
+          <a:chExt cx="0" cy="0"/>
+        </a:xfrm>
+      </p:grpSpPr>
+      <p:sp>
+        <p:nvSpPr>
+          <p:cNvPr id="2" name="슬라이드 이미지 개체 틀 1"/>
+          <p:cNvSpPr>
+            <a:spLocks noGrp="1" noRot="1" noChangeAspect="1"/>
+          </p:cNvSpPr>
+          <p:nvPr>
+            <p:ph type="sldImg"/>
+          </p:nvPr>
+        </p:nvSpPr>
+        <p:spPr/>
+      </p:sp>
+      <p:sp>
+        <p:nvSpPr>
+          <p:cNvPr id="3" name="슬라이드 노트 개체 틀 2"/>
+          <p:cNvSpPr>
+            <a:spLocks noGrp="1"/>
+          </p:cNvSpPr>
+          <p:nvPr>
+            <p:ph type="body" idx="1"/>
+          </p:nvPr>
+        </p:nvSpPr>
+        <p:spPr/>
+        <p:txBody>
+          <a:bodyPr/>
+          <a:lstStyle/>
+          <a:p>
+            <a:r>
+              <a:rPr lang="en-US" altLang="ko-KR" dirty="0"/>
+              <a:t>NTT</a:t>
+            </a:r>
+            <a:r>
+              <a:rPr lang="ko-KR" altLang="en-US" dirty="0"/>
+              <a:t>가 무엇을 다루는 장치인지만</a:t>
+            </a:r>
+            <a:r>
+              <a:rPr lang="en-US" altLang="ko-KR" dirty="0"/>
+              <a:t>..</a:t>
+            </a:r>
+            <a:endParaRPr lang="ko-KR" altLang="en-US" dirty="0"/>
+          </a:p>
+        </p:txBody>
+      </p:sp>
+      <p:sp>
+        <p:nvSpPr>
+          <p:cNvPr id="4" name="슬라이드 번호 개체 틀 3"/>
+          <p:cNvSpPr>
+            <a:spLocks noGrp="1"/>
+          </p:cNvSpPr>
+          <p:nvPr>
+            <p:ph type="sldNum" sz="quarter" idx="5"/>
+          </p:nvPr>
+        </p:nvSpPr>
+        <p:spPr/>
+        <p:txBody>
+          <a:bodyPr/>
+          <a:lstStyle/>
+          <a:p>
+            <a:fld id="{513BC5EA-D886-4875-B891-B25A6CC49088}" type="slidenum">
+              <a:rPr lang="ko-KR" altLang="en-US" smtClean="0"/>
+              <a:t>3</a:t>
+            </a:fld>
+            <a:endParaRPr lang="ko-KR" altLang="en-US" dirty="0"/>
+          </a:p>
+        </p:txBody>
+      </p:sp>
+    </p:spTree>
+    <p:extLst>
+      <p:ext uri="{BB962C8B-B14F-4D97-AF65-F5344CB8AC3E}">
+        <p14:creationId xmlns:p14="http://schemas.microsoft.com/office/powerpoint/2010/main" val="2236746307"/>
+      </p:ext>
+    </p:extLst>
+  </p:cSld>
+  <p:clrMapOvr>
+    <a:masterClrMapping/>
+  </p:clrMapOvr>
+</p:notes>
+</file>
+
 <file path=ppt/slideLayouts/slideLayout1.xml><?xml version="1.0" encoding="utf-8"?>
 <p:sldLayout xmlns:a="http://schemas.openxmlformats.org/drawingml/2006/main" xmlns:r="http://schemas.openxmlformats.org/officeDocument/2006/relationships" xmlns:p="http://schemas.openxmlformats.org/presentationml/2006/main" showMasterSp="0" type="title" preserve="1">
   <p:cSld name="제목 슬라이드">
@@ -3264,7 +3360,7 @@
             <a:fld id="{2ADF637E-82D6-4563-BCF0-C9101F2B5148}" type="datetime1">
               <a:rPr lang="ko-KR" altLang="en-US" smtClean="0"/>
               <a:pPr/>
-              <a:t>2026-08-31</a:t>
+              <a:t>2026-09-02</a:t>
             </a:fld>
             <a:endParaRPr lang="ko-KR" altLang="en-US" dirty="0"/>
           </a:p>
@@ -3479,7 +3575,7 @@
           <a:p>
             <a:fld id="{C9178607-39E6-4CB2-B3CB-AB428B3B6195}" type="datetime1">
               <a:rPr lang="ko-KR" altLang="en-US" smtClean="0"/>
-              <a:t>2026-08-31</a:t>
+              <a:t>2026-09-02</a:t>
             </a:fld>
             <a:endParaRPr lang="ko-KR" altLang="en-US" dirty="0"/>
           </a:p>
@@ -3687,7 +3783,7 @@
           <a:p>
             <a:fld id="{F578A2F2-325F-46A6-8956-F2A49A35BAF8}" type="datetime1">
               <a:rPr lang="ko-KR" altLang="en-US" smtClean="0"/>
-              <a:t>2026-08-31</a:t>
+              <a:t>2026-09-02</a:t>
             </a:fld>
             <a:endParaRPr lang="ko-KR" altLang="en-US" dirty="0"/>
           </a:p>
@@ -3939,7 +4035,7 @@
             <a:fld id="{D58CD677-7AD2-4A27-94BD-C65458D22428}" type="datetime1">
               <a:rPr lang="ko-KR" altLang="en-US" smtClean="0"/>
               <a:pPr/>
-              <a:t>2026-08-31</a:t>
+              <a:t>2026-09-02</a:t>
             </a:fld>
             <a:endParaRPr lang="ko-KR" altLang="en-US" dirty="0"/>
           </a:p>
@@ -6533,7 +6629,7 @@
           <a:p>
             <a:fld id="{2BEF52EC-B397-4D0A-AE91-E0D6840C85A1}" type="datetime1">
               <a:rPr lang="ko-KR" altLang="en-US" smtClean="0"/>
-              <a:t>2026-08-31</a:t>
+              <a:t>2026-09-02</a:t>
             </a:fld>
             <a:endParaRPr lang="ko-KR" altLang="en-US" dirty="0"/>
           </a:p>
@@ -6814,7 +6910,7 @@
           <a:p>
             <a:fld id="{32DD6007-6A42-4C9B-B218-6A32B3A38C67}" type="datetime1">
               <a:rPr lang="ko-KR" altLang="en-US" smtClean="0"/>
-              <a:t>2026-08-31</a:t>
+              <a:t>2026-09-02</a:t>
             </a:fld>
             <a:endParaRPr lang="ko-KR" altLang="en-US" dirty="0"/>
           </a:p>
@@ -7226,7 +7322,7 @@
           <a:p>
             <a:fld id="{F66658DF-8B5F-4351-A42C-BF3495DE7ABE}" type="datetime1">
               <a:rPr lang="ko-KR" altLang="en-US" smtClean="0"/>
-              <a:t>2026-08-31</a:t>
+              <a:t>2026-09-02</a:t>
             </a:fld>
             <a:endParaRPr lang="ko-KR" altLang="en-US" dirty="0"/>
           </a:p>
@@ -7367,7 +7463,7 @@
           <a:p>
             <a:fld id="{74359C48-8150-4FAB-8BEF-6AD61CFC9BBE}" type="datetime1">
               <a:rPr lang="ko-KR" altLang="en-US" smtClean="0"/>
-              <a:t>2026-08-31</a:t>
+              <a:t>2026-09-02</a:t>
             </a:fld>
             <a:endParaRPr lang="ko-KR" altLang="en-US" dirty="0"/>
           </a:p>
@@ -7480,7 +7576,7 @@
           <a:p>
             <a:fld id="{2D41DBCF-1091-470D-AC72-5CF3D00280AC}" type="datetime1">
               <a:rPr lang="ko-KR" altLang="en-US" smtClean="0"/>
-              <a:t>2026-08-31</a:t>
+              <a:t>2026-09-02</a:t>
             </a:fld>
             <a:endParaRPr lang="ko-KR" altLang="en-US" dirty="0"/>
           </a:p>
@@ -7791,7 +7887,7 @@
           <a:p>
             <a:fld id="{4024AE7C-57FB-4DBB-B90C-59145D637BF6}" type="datetime1">
               <a:rPr lang="ko-KR" altLang="en-US" smtClean="0"/>
-              <a:t>2026-08-31</a:t>
+              <a:t>2026-09-02</a:t>
             </a:fld>
             <a:endParaRPr lang="ko-KR" altLang="en-US" dirty="0"/>
           </a:p>
@@ -8079,7 +8175,7 @@
           <a:p>
             <a:fld id="{17D92253-43A0-46E3-918E-3929407A8C01}" type="datetime1">
               <a:rPr lang="ko-KR" altLang="en-US" smtClean="0"/>
-              <a:t>2026-08-31</a:t>
+              <a:t>2026-09-02</a:t>
             </a:fld>
             <a:endParaRPr lang="ko-KR" altLang="en-US" dirty="0"/>
           </a:p>
@@ -9140,7 +9236,7 @@
           <a:p>
             <a:fld id="{75D61A29-800E-482A-B0FD-5A04401ECD92}" type="datetime1">
               <a:rPr lang="ko-KR" altLang="en-US" smtClean="0"/>
-              <a:t>2026-08-31</a:t>
+              <a:t>2026-09-02</a:t>
             </a:fld>
             <a:endParaRPr lang="ko-KR" altLang="en-US" dirty="0"/>
           </a:p>

</xml_diff>

<commit_message>
add: update NTT part example
</commit_message>
<xml_diff>
--- a/presentation/0903_14_Introduction-to-Hash-Based-Signatures.pptx
+++ b/presentation/0903_14_Introduction-to-Hash-Based-Signatures.pptx
@@ -14563,26 +14563,75 @@
           <a:p>
             <a:r>
               <a:rPr sz="1800" dirty="0"/>
-              <a:t>다항식을 "계수 목록" 대신 "여러 점에서의 함숫값 목록"으로 본다 — 두 표현은 서로 오갈 수 있다</a:t>
+              <a:t>차수 ≤ 3 다항식 a(x) = a</a:t>
             </a:r>
-            <a:br>
-              <a:rPr lang="en-US" sz="1800" dirty="0"/>
-            </a:br>
+            <a:r>
+              <a:rPr sz="1800" baseline="-25000" dirty="0"/>
+              <a:t>0</a:t>
+            </a:r>
             <a:r>
               <a:rPr sz="1800" dirty="0"/>
-              <a:t>(평가 ↔ 보간)</a:t>
+              <a:t> + a</a:t>
             </a:r>
-          </a:p>
-          <a:p>
+            <a:r>
+              <a:rPr sz="1800" baseline="-25000" dirty="0"/>
+              <a:t>1</a:t>
+            </a:r>
             <a:r>
               <a:rPr sz="1800" dirty="0"/>
-              <a:t>함숫값 표현에서 곱셈은 같은 위치끼리의 곱(점별 곱) → 제곱이 아니라 항 개수에 비례</a:t>
+              <a:t> x + a</a:t>
             </a:r>
-          </a:p>
-          <a:p>
+            <a:r>
+              <a:rPr sz="1800" baseline="-25000" dirty="0"/>
+              <a:t>2</a:t>
+            </a:r>
             <a:r>
               <a:rPr sz="1800" dirty="0"/>
-              <a:t>복소수 FFT를 "소수로 나눈 나머지" 위에서 한 것 → 이름이 "수론적 변환"</a:t>
+              <a:t> x</a:t>
+            </a:r>
+            <a:r>
+              <a:rPr sz="1800" baseline="30000" dirty="0"/>
+              <a:t>2</a:t>
+            </a:r>
+            <a:r>
+              <a:rPr sz="1800" dirty="0"/>
+              <a:t> + a</a:t>
+            </a:r>
+            <a:r>
+              <a:rPr sz="1800" baseline="-25000" dirty="0"/>
+              <a:t>3</a:t>
+            </a:r>
+            <a:r>
+              <a:rPr sz="1800" dirty="0"/>
+              <a:t> x</a:t>
+            </a:r>
+            <a:r>
+              <a:rPr sz="1800" baseline="30000" dirty="0"/>
+              <a:t>3</a:t>
+            </a:r>
+            <a:r>
+              <a:rPr sz="1800" dirty="0"/>
+              <a:t> 을 보는 두 방식 — "계수 목록" 또는 "서로 다른 4개 점에서의 함숫값 목록"</a:t>
+            </a:r>
+          </a:p>
+          <a:p>
+            <a:r>
+              <a:rPr sz="1800" dirty="0"/>
+              <a:t>차수 ≤ 3 다항식은 서로 다른 4개 점의 값이면 유일하게 복원된다 → 두 표현은 정보량이 같고, 평가 ↔ 보간으로 자유롭게 오간다</a:t>
+            </a:r>
+          </a:p>
+          <a:p>
+            <a:r>
+              <a:rPr sz="1800" dirty="0"/>
+              <a:t>값 표현에서는 곱셈이 같은 위치의 값끼리의 곱(점별 곱) → O(n</a:t>
+            </a:r>
+            <a:r>
+              <a:rPr sz="1800" baseline="30000" dirty="0"/>
+              <a:t>2</a:t>
+            </a:r>
+            <a:r>
+              <a:rPr sz="1800" dirty="0"/>
+              <a:t>)이 아니라 O(n)</a:t>
             </a:r>
           </a:p>
         </p:txBody>
@@ -14619,14 +14668,14 @@
           <p:nvPr>
             <p:extLst>
               <p:ext uri="{D42A27DB-BD31-4B8C-83A1-F6EECF244321}">
-                <p14:modId xmlns:p14="http://schemas.microsoft.com/office/powerpoint/2010/main" val="1629459383"/>
+                <p14:modId xmlns:p14="http://schemas.microsoft.com/office/powerpoint/2010/main" val="2710925536"/>
               </p:ext>
             </p:extLst>
           </p:nvPr>
         </p:nvGraphicFramePr>
         <p:xfrm>
-          <a:off x="841248" y="3645866"/>
-          <a:ext cx="10512552" cy="1463040"/>
+          <a:off x="838200" y="3947238"/>
+          <a:ext cx="10512552" cy="1615440"/>
         </p:xfrm>
         <a:graphic>
           <a:graphicData uri="http://schemas.openxmlformats.org/drawingml/2006/table">
@@ -14728,7 +14777,7 @@
                             <a:schemeClr val="bg1"/>
                           </a:solidFill>
                         </a:rPr>
-                        <a:t>담고 있는 것</a:t>
+                        <a:t>데이터</a:t>
                       </a:r>
                     </a:p>
                   </a:txBody>
@@ -14899,7 +14948,39 @@
                       <a:pPr algn="ctr"/>
                       <a:r>
                         <a:rPr sz="1800" dirty="0"/>
-                        <a:t>계수 n개</a:t>
+                        <a:t>(a</a:t>
+                      </a:r>
+                      <a:r>
+                        <a:rPr sz="1800" baseline="-25000" dirty="0"/>
+                        <a:t>0</a:t>
+                      </a:r>
+                      <a:r>
+                        <a:rPr sz="1800" dirty="0"/>
+                        <a:t>, a</a:t>
+                      </a:r>
+                      <a:r>
+                        <a:rPr sz="1800" baseline="-25000" dirty="0"/>
+                        <a:t>1</a:t>
+                      </a:r>
+                      <a:r>
+                        <a:rPr sz="1800" dirty="0"/>
+                        <a:t>, a</a:t>
+                      </a:r>
+                      <a:r>
+                        <a:rPr sz="1800" baseline="-25000" dirty="0"/>
+                        <a:t>2</a:t>
+                      </a:r>
+                      <a:r>
+                        <a:rPr sz="1800" dirty="0"/>
+                        <a:t>, a</a:t>
+                      </a:r>
+                      <a:r>
+                        <a:rPr sz="1800" baseline="-25000" dirty="0"/>
+                        <a:t>3</a:t>
+                      </a:r>
+                      <a:r>
+                        <a:rPr sz="1800" dirty="0"/>
+                        <a:t>)</a:t>
                       </a:r>
                     </a:p>
                   </a:txBody>
@@ -14951,7 +15032,15 @@
                       <a:pPr algn="ctr"/>
                       <a:r>
                         <a:rPr sz="1800" dirty="0"/>
-                        <a:t>항 개수의 제곱</a:t>
+                        <a:t>비쌈 — 모든 항 × 모든 항, O(n</a:t>
+                      </a:r>
+                      <a:r>
+                        <a:rPr sz="1800" baseline="30000" dirty="0"/>
+                        <a:t>2</a:t>
+                      </a:r>
+                      <a:r>
+                        <a:rPr sz="1800" dirty="0"/>
+                        <a:t>)</a:t>
                       </a:r>
                     </a:p>
                   </a:txBody>
@@ -15010,7 +15099,7 @@
                       <a:pPr algn="ctr"/>
                       <a:r>
                         <a:rPr sz="1800" dirty="0"/>
-                        <a:t>함숫값 표현</a:t>
+                        <a:t>값 표현</a:t>
                       </a:r>
                     </a:p>
                   </a:txBody>
@@ -15062,7 +15151,39 @@
                       <a:pPr algn="ctr"/>
                       <a:r>
                         <a:rPr sz="1800" dirty="0"/>
-                        <a:t>여러 점에서의 함숫값 n개</a:t>
+                        <a:t>4개 점에서의 함숫값 (a(p</a:t>
+                      </a:r>
+                      <a:r>
+                        <a:rPr sz="1800" baseline="-25000" dirty="0"/>
+                        <a:t>1</a:t>
+                      </a:r>
+                      <a:r>
+                        <a:rPr sz="1800" dirty="0"/>
+                        <a:t>), a(p</a:t>
+                      </a:r>
+                      <a:r>
+                        <a:rPr sz="1800" baseline="-25000" dirty="0"/>
+                        <a:t>2</a:t>
+                      </a:r>
+                      <a:r>
+                        <a:rPr sz="1800" dirty="0"/>
+                        <a:t>), a(p</a:t>
+                      </a:r>
+                      <a:r>
+                        <a:rPr sz="1800" baseline="-25000" dirty="0"/>
+                        <a:t>3</a:t>
+                      </a:r>
+                      <a:r>
+                        <a:rPr sz="1800" dirty="0"/>
+                        <a:t>), a(p</a:t>
+                      </a:r>
+                      <a:r>
+                        <a:rPr sz="1800" baseline="-25000" dirty="0"/>
+                        <a:t>4</a:t>
+                      </a:r>
+                      <a:r>
+                        <a:rPr sz="1800" dirty="0"/>
+                        <a:t>))</a:t>
                       </a:r>
                     </a:p>
                   </a:txBody>
@@ -15114,7 +15235,7 @@
                       <a:pPr algn="ctr"/>
                       <a:r>
                         <a:rPr sz="1800" dirty="0"/>
-                        <a:t>항 개수에 비례 (점별 곱)</a:t>
+                        <a:t>쌈 — 같은 위치끼리 곱, O(n)</a:t>
                       </a:r>
                     </a:p>
                   </a:txBody>

</xml_diff>

<commit_message>
add: modify NTT part word
</commit_message>
<xml_diff>
--- a/presentation/0903_14_Introduction-to-Hash-Based-Signatures.pptx
+++ b/presentation/0903_14_Introduction-to-Hash-Based-Signatures.pptx
@@ -14668,7 +14668,7 @@
           <p:nvPr>
             <p:extLst>
               <p:ext uri="{D42A27DB-BD31-4B8C-83A1-F6EECF244321}">
-                <p14:modId xmlns:p14="http://schemas.microsoft.com/office/powerpoint/2010/main" val="2710925536"/>
+                <p14:modId xmlns:p14="http://schemas.microsoft.com/office/powerpoint/2010/main" val="4101062300"/>
               </p:ext>
             </p:extLst>
           </p:nvPr>
@@ -15151,7 +15151,14 @@
                       <a:pPr algn="ctr"/>
                       <a:r>
                         <a:rPr sz="1800" dirty="0"/>
-                        <a:t>4개 점에서의 함숫값 (a(p</a:t>
+                        <a:t>4개 점에서의 함숫값</a:t>
+                      </a:r>
+                      <a:br>
+                        <a:rPr lang="en-US" sz="1800" dirty="0"/>
+                      </a:br>
+                      <a:r>
+                        <a:rPr sz="1800" dirty="0"/>
+                        <a:t>(a(p</a:t>
                       </a:r>
                       <a:r>
                         <a:rPr sz="1800" baseline="-25000" dirty="0"/>

</xml_diff>